<commit_message>
Finalize SMB bundles deliverables
</commit_message>
<xml_diff>
--- a/deliverables/smb_bundles/smb_bundles_1_identify.pptx
+++ b/deliverables/smb_bundles/smb_bundles_1_identify.pptx
@@ -122,6 +122,143 @@
 </p:presentation>
 </file>
 
+<file path=ppt/authors.xml><?xml version="1.0" encoding="utf-8"?>
+<p188:authorLst xmlns:a="http://schemas.openxmlformats.org/drawingml/2006/main" xmlns:r="http://schemas.openxmlformats.org/officeDocument/2006/relationships" xmlns:p188="http://schemas.microsoft.com/office/powerpoint/2018/8/main">
+  <p188:author id="{415BEED1-CB72-B48E-F02F-A910FFABA975}" name="Omer Tal" initials="OT" userId="4873ff6cd3b5db54" providerId="Windows Live"/>
+</p188:authorLst>
+</file>
+
+<file path=ppt/comments/modernComment_101_5D540259.xml><?xml version="1.0" encoding="utf-8"?>
+<p188:cmLst xmlns:a="http://schemas.openxmlformats.org/drawingml/2006/main" xmlns:r="http://schemas.openxmlformats.org/officeDocument/2006/relationships" xmlns:p188="http://schemas.microsoft.com/office/powerpoint/2018/8/main">
+  <p188:cm id="{EEDB1040-B1A8-934B-AD3D-2513803A409B}" authorId="{415BEED1-CB72-B48E-F02F-A910FFABA975}" created="2026-06-15T20:10:53.991">
+    <ac:deMkLst xmlns:ac="http://schemas.microsoft.com/office/drawing/2013/main/command">
+      <pc:docMk xmlns:pc="http://schemas.microsoft.com/office/powerpoint/2013/main/command"/>
+      <pc:sldMk xmlns:pc="http://schemas.microsoft.com/office/powerpoint/2013/main/command" cId="1565786713" sldId="257"/>
+      <ac:spMk id="46" creationId="{47D1F815-DDE6-4E60-B387-97C475589306}"/>
+    </ac:deMkLst>
+    <p188:txBody>
+      <a:bodyPr/>
+      <a:lstStyle/>
+      <a:p>
+        <a:r>
+          <a:rPr lang="en-US"/>
+          <a:t>remove</a:t>
+        </a:r>
+      </a:p>
+    </p188:txBody>
+  </p188:cm>
+  <p188:cm id="{254AA85D-B778-034B-B2D2-D1BC2066CA44}" authorId="{415BEED1-CB72-B48E-F02F-A910FFABA975}" created="2026-06-15T20:11:12.574">
+    <ac:deMkLst xmlns:ac="http://schemas.microsoft.com/office/drawing/2013/main/command">
+      <pc:docMk xmlns:pc="http://schemas.microsoft.com/office/powerpoint/2013/main/command"/>
+      <pc:sldMk xmlns:pc="http://schemas.microsoft.com/office/powerpoint/2013/main/command" cId="1565786713" sldId="257"/>
+      <ac:spMk id="10" creationId="{2178FA77-A0E9-4651-8A84-AC52DF717621}"/>
+    </ac:deMkLst>
+    <p188:txBody>
+      <a:bodyPr/>
+      <a:lstStyle/>
+      <a:p>
+        <a:r>
+          <a:rPr lang="en-US"/>
+          <a:t>do not get into details</a:t>
+        </a:r>
+      </a:p>
+    </p188:txBody>
+  </p188:cm>
+</p188:cmLst>
+</file>
+
+<file path=ppt/comments/modernComment_103_67150090.xml><?xml version="1.0" encoding="utf-8"?>
+<p188:cmLst xmlns:a="http://schemas.openxmlformats.org/drawingml/2006/main" xmlns:r="http://schemas.openxmlformats.org/officeDocument/2006/relationships" xmlns:p188="http://schemas.microsoft.com/office/powerpoint/2018/8/main">
+  <p188:cm id="{0BB568F2-B6FB-764D-A7C3-AD5A6465D937}" authorId="{415BEED1-CB72-B48E-F02F-A910FFABA975}" created="2026-06-15T20:12:44.574">
+    <ac:deMkLst xmlns:ac="http://schemas.microsoft.com/office/drawing/2013/main/command">
+      <pc:docMk xmlns:pc="http://schemas.microsoft.com/office/powerpoint/2013/main/command"/>
+      <pc:sldMk xmlns:pc="http://schemas.microsoft.com/office/powerpoint/2013/main/command" cId="1729429648" sldId="259"/>
+      <ac:graphicFrameMk id="17" creationId="{00000000-0000-0000-0000-000000000000}"/>
+    </ac:deMkLst>
+    <p188:txBody>
+      <a:bodyPr/>
+      <a:lstStyle/>
+      <a:p>
+        <a:r>
+          <a:rPr lang="en-US"/>
+          <a:t>reorder: CPC, Invoice amount first</a:t>
+        </a:r>
+      </a:p>
+    </p188:txBody>
+  </p188:cm>
+</p188:cmLst>
+</file>
+
+<file path=ppt/comments/modernComment_106_66FA96F5.xml><?xml version="1.0" encoding="utf-8"?>
+<p188:cmLst xmlns:a="http://schemas.openxmlformats.org/drawingml/2006/main" xmlns:r="http://schemas.openxmlformats.org/officeDocument/2006/relationships" xmlns:p188="http://schemas.microsoft.com/office/powerpoint/2018/8/main">
+  <p188:cm id="{4457C0FB-C6B6-B64D-9351-EF8663339985}" authorId="{415BEED1-CB72-B48E-F02F-A910FFABA975}" created="2026-06-15T19:31:56.213">
+    <pc:sldMkLst xmlns:pc="http://schemas.microsoft.com/office/powerpoint/2013/main/command">
+      <pc:docMk/>
+      <pc:sldMk cId="1727698677" sldId="262"/>
+    </pc:sldMkLst>
+    <p188:txBody>
+      <a:bodyPr/>
+      <a:lstStyle/>
+      <a:p>
+        <a:r>
+          <a:rPr lang="en-US"/>
+          <a:t>Remove this signal</a:t>
+        </a:r>
+      </a:p>
+    </p188:txBody>
+  </p188:cm>
+</p188:cmLst>
+</file>
+
+<file path=ppt/comments/modernComment_107_4490B3C.xml><?xml version="1.0" encoding="utf-8"?>
+<p188:cmLst xmlns:a="http://schemas.openxmlformats.org/drawingml/2006/main" xmlns:r="http://schemas.openxmlformats.org/officeDocument/2006/relationships" xmlns:p188="http://schemas.microsoft.com/office/powerpoint/2018/8/main">
+  <p188:cm id="{EC7A623E-11A8-EB4D-A9D4-A9CFC9D399BF}" authorId="{415BEED1-CB72-B48E-F02F-A910FFABA975}" created="2026-06-15T19:33:23.080">
+    <ac:txMkLst xmlns:ac="http://schemas.microsoft.com/office/drawing/2013/main/command">
+      <pc:docMk xmlns:pc="http://schemas.microsoft.com/office/powerpoint/2013/main/command"/>
+      <pc:sldMk xmlns:pc="http://schemas.microsoft.com/office/powerpoint/2013/main/command" cId="71895868" sldId="263"/>
+      <ac:graphicFrameMk id="10" creationId="{00000000-0000-0000-0000-000000000000}"/>
+      <ac:tblMk/>
+      <ac:tcMk rowId="10003" colId="20001"/>
+      <ac:txMk cp="0" len="45">
+        <ac:context len="46" hash="2602481956"/>
+      </ac:txMk>
+    </ac:txMkLst>
+    <p188:pos x="4442883" y="1454083"/>
+    <p188:txBody>
+      <a:bodyPr/>
+      <a:lstStyle/>
+      <a:p>
+        <a:r>
+          <a:rPr lang="en-US"/>
+          <a:t>rephrase</a:t>
+        </a:r>
+      </a:p>
+    </p188:txBody>
+  </p188:cm>
+  <p188:cm id="{C8FDF3E7-26C1-A548-A8B3-ED9686E3BE31}" authorId="{415BEED1-CB72-B48E-F02F-A910FFABA975}" created="2026-06-15T19:33:49.879">
+    <ac:txMkLst xmlns:ac="http://schemas.microsoft.com/office/drawing/2013/main/command">
+      <pc:docMk xmlns:pc="http://schemas.microsoft.com/office/powerpoint/2013/main/command"/>
+      <pc:sldMk xmlns:pc="http://schemas.microsoft.com/office/powerpoint/2013/main/command" cId="71895868" sldId="263"/>
+      <ac:spMk id="12" creationId="{E6D23BF3-2401-4FDA-BDDF-486C1AD3B8B9}"/>
+      <ac:txMk cp="0" len="101">
+        <ac:context len="102" hash="1162065837"/>
+      </ac:txMk>
+    </ac:txMkLst>
+    <p188:pos x="6525683" y="338600"/>
+    <p188:txBody>
+      <a:bodyPr/>
+      <a:lstStyle/>
+      <a:p>
+        <a:r>
+          <a:rPr lang="en-US"/>
+          <a:t>rephrase</a:t>
+        </a:r>
+      </a:p>
+    </p188:txBody>
+  </p188:cm>
+</p188:cmLst>
+</file>
+
 <file path=ppt/notesMasters/notesMaster1.xml><?xml version="1.0" encoding="utf-8"?>
 <p:notesMaster xmlns:a="http://schemas.openxmlformats.org/drawingml/2006/main" xmlns:r="http://schemas.openxmlformats.org/officeDocument/2006/relationships" xmlns:p="http://schemas.openxmlformats.org/presentationml/2006/main">
   <p:cSld>
@@ -787,7 +924,7 @@
           <a:bodyPr/>
           <a:lstStyle/>
           <a:p>
-            <a:endParaRPr/>
+            <a:endParaRPr dirty="0"/>
           </a:p>
         </p:txBody>
       </p:sp>
@@ -2296,7 +2433,7 @@
               <a:buNone/>
             </a:pPr>
             <a:r>
-              <a:rPr sz="1800" b="1">
+              <a:rPr sz="1800" b="1" dirty="0">
                 <a:solidFill>
                   <a:srgbClr val="FFD426"/>
                 </a:solidFill>
@@ -2329,7 +2466,9 @@
             <a:ext cx="2087880" cy="1466850"/>
           </a:xfrm>
           <a:prstGeom prst="roundRect">
-            <a:avLst/>
+            <a:avLst>
+              <a:gd name="adj" fmla="val 7000"/>
+            </a:avLst>
           </a:prstGeom>
           <a:solidFill>
             <a:srgbClr val="0E0E0E"/>
@@ -2344,6 +2483,7 @@
           <a:bodyPr/>
           <a:lstStyle/>
           <a:p>
+            <a:pPr marL="0" indent="0" algn="l" defTabSz="914400" rtl="0"/>
             <a:endParaRPr/>
           </a:p>
         </p:txBody>
@@ -2447,168 +2587,6 @@
       </p:sp>
       <p:sp>
         <p:nvSpPr>
-          <p:cNvPr id="14" name="Signal bullet">
-            <a:extLst>
-              <a:ext uri="{FF2B5EF4-FFF2-40B4-BE49-F238E27FC236}">
-                <a16:creationId xmlns:a16="http://schemas.microsoft.com/office/drawing/2014/main" id="{7B56A51E-5F3E-422F-80C4-58E8EE88FB23}"/>
-              </a:ext>
-            </a:extLst>
-          </p:cNvPr>
-          <p:cNvSpPr>
-            <a:spLocks noGrp="1"/>
-          </p:cNvSpPr>
-          <p:nvPr/>
-        </p:nvSpPr>
-        <p:spPr>
-          <a:xfrm>
-            <a:off x="781050" y="3215712"/>
-            <a:ext cx="66675" cy="66675"/>
-          </a:xfrm>
-          <a:prstGeom prst="ellipse">
-            <a:avLst/>
-          </a:prstGeom>
-          <a:solidFill>
-            <a:srgbClr val="FFD426"/>
-          </a:solidFill>
-          <a:ln w="0">
-            <a:noFill/>
-          </a:ln>
-        </p:spPr>
-        <p:txBody>
-          <a:bodyPr/>
-          <a:lstStyle/>
-          <a:p>
-            <a:endParaRPr/>
-          </a:p>
-        </p:txBody>
-      </p:sp>
-      <p:sp>
-        <p:nvSpPr>
-          <p:cNvPr id="15" name="Business Setup item">
-            <a:extLst>
-              <a:ext uri="{FF2B5EF4-FFF2-40B4-BE49-F238E27FC236}">
-                <a16:creationId xmlns:a16="http://schemas.microsoft.com/office/drawing/2014/main" id="{B4FC3418-FD5C-45BD-AC2C-BC074CB59259}"/>
-              </a:ext>
-            </a:extLst>
-          </p:cNvPr>
-          <p:cNvSpPr>
-            <a:spLocks noGrp="1"/>
-          </p:cNvSpPr>
-          <p:nvPr/>
-        </p:nvSpPr>
-        <p:spPr>
-          <a:xfrm>
-            <a:off x="914400" y="3149037"/>
-            <a:ext cx="1630680" cy="323850"/>
-          </a:xfrm>
-          <a:prstGeom prst="rect">
-            <a:avLst/>
-          </a:prstGeom>
-        </p:spPr>
-        <p:txBody>
-          <a:bodyPr wrap="square" lIns="0" tIns="0" rIns="0" bIns="0" anchor="t"/>
-          <a:lstStyle/>
-          <a:p>
-            <a:pPr marL="0" indent="0">
-              <a:buNone/>
-            </a:pPr>
-            <a:r>
-              <a:rPr sz="1300">
-                <a:solidFill>
-                  <a:srgbClr val="D8D8D2"/>
-                </a:solidFill>
-                <a:latin typeface="Arial"/>
-                <a:ea typeface="Arial"/>
-                <a:cs typeface="Arial"/>
-              </a:rPr>
-              <a:t>Corporate bank flag</a:t>
-            </a:r>
-          </a:p>
-        </p:txBody>
-      </p:sp>
-      <p:sp>
-        <p:nvSpPr>
-          <p:cNvPr id="16" name="Signal bullet">
-            <a:extLst>
-              <a:ext uri="{FF2B5EF4-FFF2-40B4-BE49-F238E27FC236}">
-                <a16:creationId xmlns:a16="http://schemas.microsoft.com/office/drawing/2014/main" id="{B14A1CE9-D141-4F64-A7EF-D4B4BF92A59E}"/>
-              </a:ext>
-            </a:extLst>
-          </p:cNvPr>
-          <p:cNvSpPr>
-            <a:spLocks noGrp="1"/>
-          </p:cNvSpPr>
-          <p:nvPr/>
-        </p:nvSpPr>
-        <p:spPr>
-          <a:xfrm>
-            <a:off x="781050" y="3625287"/>
-            <a:ext cx="66675" cy="66675"/>
-          </a:xfrm>
-          <a:prstGeom prst="ellipse">
-            <a:avLst/>
-          </a:prstGeom>
-          <a:solidFill>
-            <a:srgbClr val="FFD426"/>
-          </a:solidFill>
-          <a:ln w="0">
-            <a:noFill/>
-          </a:ln>
-        </p:spPr>
-        <p:txBody>
-          <a:bodyPr/>
-          <a:lstStyle/>
-          <a:p>
-            <a:endParaRPr/>
-          </a:p>
-        </p:txBody>
-      </p:sp>
-      <p:sp>
-        <p:nvSpPr>
-          <p:cNvPr id="17" name="Business Setup item">
-            <a:extLst>
-              <a:ext uri="{FF2B5EF4-FFF2-40B4-BE49-F238E27FC236}">
-                <a16:creationId xmlns:a16="http://schemas.microsoft.com/office/drawing/2014/main" id="{B469ED38-7D8B-4DE8-9700-530B606571D5}"/>
-              </a:ext>
-            </a:extLst>
-          </p:cNvPr>
-          <p:cNvSpPr>
-            <a:spLocks noGrp="1"/>
-          </p:cNvSpPr>
-          <p:nvPr/>
-        </p:nvSpPr>
-        <p:spPr>
-          <a:xfrm>
-            <a:off x="914400" y="3558612"/>
-            <a:ext cx="1630680" cy="323850"/>
-          </a:xfrm>
-          <a:prstGeom prst="rect">
-            <a:avLst/>
-          </a:prstGeom>
-        </p:spPr>
-        <p:txBody>
-          <a:bodyPr wrap="square" lIns="0" tIns="0" rIns="0" bIns="0" anchor="t"/>
-          <a:lstStyle/>
-          <a:p>
-            <a:pPr marL="0" indent="0">
-              <a:buNone/>
-            </a:pPr>
-            <a:r>
-              <a:rPr sz="1300">
-                <a:solidFill>
-                  <a:srgbClr val="D8D8D2"/>
-                </a:solidFill>
-                <a:latin typeface="Arial"/>
-                <a:ea typeface="Arial"/>
-                <a:cs typeface="Arial"/>
-              </a:rPr>
-              <a:t>External URL</a:t>
-            </a:r>
-          </a:p>
-        </p:txBody>
-      </p:sp>
-      <p:sp>
-        <p:nvSpPr>
           <p:cNvPr id="18" name="Paid Usage card">
             <a:extLst>
               <a:ext uri="{FF2B5EF4-FFF2-40B4-BE49-F238E27FC236}">
@@ -2627,7 +2605,9 @@
             <a:ext cx="2087880" cy="1466850"/>
           </a:xfrm>
           <a:prstGeom prst="roundRect">
-            <a:avLst/>
+            <a:avLst>
+              <a:gd name="adj" fmla="val 7000"/>
+            </a:avLst>
           </a:prstGeom>
           <a:solidFill>
             <a:srgbClr val="0E0E0E"/>
@@ -2742,168 +2722,6 @@
       </p:sp>
       <p:sp>
         <p:nvSpPr>
-          <p:cNvPr id="21" name="Signal bullet">
-            <a:extLst>
-              <a:ext uri="{FF2B5EF4-FFF2-40B4-BE49-F238E27FC236}">
-                <a16:creationId xmlns:a16="http://schemas.microsoft.com/office/drawing/2014/main" id="{CA725DE6-45B1-4EFE-B3C9-EF75F8B52A9A}"/>
-              </a:ext>
-            </a:extLst>
-          </p:cNvPr>
-          <p:cNvSpPr>
-            <a:spLocks noGrp="1"/>
-          </p:cNvSpPr>
-          <p:nvPr/>
-        </p:nvSpPr>
-        <p:spPr>
-          <a:xfrm>
-            <a:off x="3002280" y="3215712"/>
-            <a:ext cx="66675" cy="66675"/>
-          </a:xfrm>
-          <a:prstGeom prst="ellipse">
-            <a:avLst/>
-          </a:prstGeom>
-          <a:solidFill>
-            <a:srgbClr val="FFD426"/>
-          </a:solidFill>
-          <a:ln w="0">
-            <a:noFill/>
-          </a:ln>
-        </p:spPr>
-        <p:txBody>
-          <a:bodyPr/>
-          <a:lstStyle/>
-          <a:p>
-            <a:endParaRPr/>
-          </a:p>
-        </p:txBody>
-      </p:sp>
-      <p:sp>
-        <p:nvSpPr>
-          <p:cNvPr id="22" name="Paid Usage item">
-            <a:extLst>
-              <a:ext uri="{FF2B5EF4-FFF2-40B4-BE49-F238E27FC236}">
-                <a16:creationId xmlns:a16="http://schemas.microsoft.com/office/drawing/2014/main" id="{0675CBDE-5BDB-4CA7-ABBF-BA7C7327CCA2}"/>
-              </a:ext>
-            </a:extLst>
-          </p:cNvPr>
-          <p:cNvSpPr>
-            <a:spLocks noGrp="1"/>
-          </p:cNvSpPr>
-          <p:nvPr/>
-        </p:nvSpPr>
-        <p:spPr>
-          <a:xfrm>
-            <a:off x="3135630" y="3149037"/>
-            <a:ext cx="1630680" cy="323850"/>
-          </a:xfrm>
-          <a:prstGeom prst="rect">
-            <a:avLst/>
-          </a:prstGeom>
-        </p:spPr>
-        <p:txBody>
-          <a:bodyPr wrap="square" lIns="0" tIns="0" rIns="0" bIns="0" anchor="t"/>
-          <a:lstStyle/>
-          <a:p>
-            <a:pPr marL="0" indent="0">
-              <a:buNone/>
-            </a:pPr>
-            <a:r>
-              <a:rPr sz="1300">
-                <a:solidFill>
-                  <a:srgbClr val="D8D8D2"/>
-                </a:solidFill>
-                <a:latin typeface="Arial"/>
-                <a:ea typeface="Arial"/>
-                <a:cs typeface="Arial"/>
-              </a:rPr>
-              <a:t>Paid features</a:t>
-            </a:r>
-          </a:p>
-        </p:txBody>
-      </p:sp>
-      <p:sp>
-        <p:nvSpPr>
-          <p:cNvPr id="23" name="Signal bullet">
-            <a:extLst>
-              <a:ext uri="{FF2B5EF4-FFF2-40B4-BE49-F238E27FC236}">
-                <a16:creationId xmlns:a16="http://schemas.microsoft.com/office/drawing/2014/main" id="{21856CE8-A264-4587-95B3-029FD2FBDEDD}"/>
-              </a:ext>
-            </a:extLst>
-          </p:cNvPr>
-          <p:cNvSpPr>
-            <a:spLocks noGrp="1"/>
-          </p:cNvSpPr>
-          <p:nvPr/>
-        </p:nvSpPr>
-        <p:spPr>
-          <a:xfrm>
-            <a:off x="3002280" y="3625287"/>
-            <a:ext cx="66675" cy="66675"/>
-          </a:xfrm>
-          <a:prstGeom prst="ellipse">
-            <a:avLst/>
-          </a:prstGeom>
-          <a:solidFill>
-            <a:srgbClr val="FFD426"/>
-          </a:solidFill>
-          <a:ln w="0">
-            <a:noFill/>
-          </a:ln>
-        </p:spPr>
-        <p:txBody>
-          <a:bodyPr/>
-          <a:lstStyle/>
-          <a:p>
-            <a:endParaRPr/>
-          </a:p>
-        </p:txBody>
-      </p:sp>
-      <p:sp>
-        <p:nvSpPr>
-          <p:cNvPr id="24" name="Paid Usage item">
-            <a:extLst>
-              <a:ext uri="{FF2B5EF4-FFF2-40B4-BE49-F238E27FC236}">
-                <a16:creationId xmlns:a16="http://schemas.microsoft.com/office/drawing/2014/main" id="{77ECC5B7-96DB-4BA4-BF5D-832D68C65387}"/>
-              </a:ext>
-            </a:extLst>
-          </p:cNvPr>
-          <p:cNvSpPr>
-            <a:spLocks noGrp="1"/>
-          </p:cNvSpPr>
-          <p:nvPr/>
-        </p:nvSpPr>
-        <p:spPr>
-          <a:xfrm>
-            <a:off x="3135630" y="3558612"/>
-            <a:ext cx="1630680" cy="323850"/>
-          </a:xfrm>
-          <a:prstGeom prst="rect">
-            <a:avLst/>
-          </a:prstGeom>
-        </p:spPr>
-        <p:txBody>
-          <a:bodyPr wrap="square" lIns="0" tIns="0" rIns="0" bIns="0" anchor="t"/>
-          <a:lstStyle/>
-          <a:p>
-            <a:pPr marL="0" indent="0">
-              <a:buNone/>
-            </a:pPr>
-            <a:r>
-              <a:rPr sz="1300">
-                <a:solidFill>
-                  <a:srgbClr val="D8D8D2"/>
-                </a:solidFill>
-                <a:latin typeface="Arial"/>
-                <a:ea typeface="Arial"/>
-                <a:cs typeface="Arial"/>
-              </a:rPr>
-              <a:t>Pro CPC, invoices</a:t>
-            </a:r>
-          </a:p>
-        </p:txBody>
-      </p:sp>
-      <p:sp>
-        <p:nvSpPr>
           <p:cNvPr id="25" name="Seller Activity card">
             <a:extLst>
               <a:ext uri="{FF2B5EF4-FFF2-40B4-BE49-F238E27FC236}">
@@ -2922,7 +2740,9 @@
             <a:ext cx="2087880" cy="1466850"/>
           </a:xfrm>
           <a:prstGeom prst="roundRect">
-            <a:avLst/>
+            <a:avLst>
+              <a:gd name="adj" fmla="val 7000"/>
+            </a:avLst>
           </a:prstGeom>
           <a:solidFill>
             <a:srgbClr val="0E0E0E"/>
@@ -3026,168 +2846,6 @@
       </p:sp>
       <p:sp>
         <p:nvSpPr>
-          <p:cNvPr id="28" name="Signal bullet">
-            <a:extLst>
-              <a:ext uri="{FF2B5EF4-FFF2-40B4-BE49-F238E27FC236}">
-                <a16:creationId xmlns:a16="http://schemas.microsoft.com/office/drawing/2014/main" id="{144F21A3-D738-452D-AAE6-160D2E809261}"/>
-              </a:ext>
-            </a:extLst>
-          </p:cNvPr>
-          <p:cNvSpPr>
-            <a:spLocks noGrp="1"/>
-          </p:cNvSpPr>
-          <p:nvPr/>
-        </p:nvSpPr>
-        <p:spPr>
-          <a:xfrm>
-            <a:off x="5223510" y="3215712"/>
-            <a:ext cx="66675" cy="66675"/>
-          </a:xfrm>
-          <a:prstGeom prst="ellipse">
-            <a:avLst/>
-          </a:prstGeom>
-          <a:solidFill>
-            <a:srgbClr val="FFD426"/>
-          </a:solidFill>
-          <a:ln w="0">
-            <a:noFill/>
-          </a:ln>
-        </p:spPr>
-        <p:txBody>
-          <a:bodyPr/>
-          <a:lstStyle/>
-          <a:p>
-            <a:endParaRPr/>
-          </a:p>
-        </p:txBody>
-      </p:sp>
-      <p:sp>
-        <p:nvSpPr>
-          <p:cNvPr id="29" name="Seller Activity item">
-            <a:extLst>
-              <a:ext uri="{FF2B5EF4-FFF2-40B4-BE49-F238E27FC236}">
-                <a16:creationId xmlns:a16="http://schemas.microsoft.com/office/drawing/2014/main" id="{49F3CCD9-43DB-4DF4-9E52-3895C28C1A51}"/>
-              </a:ext>
-            </a:extLst>
-          </p:cNvPr>
-          <p:cNvSpPr>
-            <a:spLocks noGrp="1"/>
-          </p:cNvSpPr>
-          <p:nvPr/>
-        </p:nvSpPr>
-        <p:spPr>
-          <a:xfrm>
-            <a:off x="5356860" y="3149037"/>
-            <a:ext cx="1630680" cy="323850"/>
-          </a:xfrm>
-          <a:prstGeom prst="rect">
-            <a:avLst/>
-          </a:prstGeom>
-        </p:spPr>
-        <p:txBody>
-          <a:bodyPr wrap="square" lIns="0" tIns="0" rIns="0" bIns="0" anchor="t"/>
-          <a:lstStyle/>
-          <a:p>
-            <a:pPr marL="0" indent="0">
-              <a:buNone/>
-            </a:pPr>
-            <a:r>
-              <a:rPr sz="1300">
-                <a:solidFill>
-                  <a:srgbClr val="D8D8D2"/>
-                </a:solidFill>
-                <a:latin typeface="Arial"/>
-                <a:ea typeface="Arial"/>
-                <a:cs typeface="Arial"/>
-              </a:rPr>
-              <a:t>Listing volume</a:t>
-            </a:r>
-          </a:p>
-        </p:txBody>
-      </p:sp>
-      <p:sp>
-        <p:nvSpPr>
-          <p:cNvPr id="30" name="Signal bullet">
-            <a:extLst>
-              <a:ext uri="{FF2B5EF4-FFF2-40B4-BE49-F238E27FC236}">
-                <a16:creationId xmlns:a16="http://schemas.microsoft.com/office/drawing/2014/main" id="{8BC7A4E6-11F4-43B9-9D4F-3980FAEC70AE}"/>
-              </a:ext>
-            </a:extLst>
-          </p:cNvPr>
-          <p:cNvSpPr>
-            <a:spLocks noGrp="1"/>
-          </p:cNvSpPr>
-          <p:nvPr/>
-        </p:nvSpPr>
-        <p:spPr>
-          <a:xfrm>
-            <a:off x="5223510" y="3625287"/>
-            <a:ext cx="66675" cy="66675"/>
-          </a:xfrm>
-          <a:prstGeom prst="ellipse">
-            <a:avLst/>
-          </a:prstGeom>
-          <a:solidFill>
-            <a:srgbClr val="FFD426"/>
-          </a:solidFill>
-          <a:ln w="0">
-            <a:noFill/>
-          </a:ln>
-        </p:spPr>
-        <p:txBody>
-          <a:bodyPr/>
-          <a:lstStyle/>
-          <a:p>
-            <a:endParaRPr/>
-          </a:p>
-        </p:txBody>
-      </p:sp>
-      <p:sp>
-        <p:nvSpPr>
-          <p:cNvPr id="31" name="Seller Activity item">
-            <a:extLst>
-              <a:ext uri="{FF2B5EF4-FFF2-40B4-BE49-F238E27FC236}">
-                <a16:creationId xmlns:a16="http://schemas.microsoft.com/office/drawing/2014/main" id="{0E9B555A-9C31-4082-A516-9A9DEA35A176}"/>
-              </a:ext>
-            </a:extLst>
-          </p:cNvPr>
-          <p:cNvSpPr>
-            <a:spLocks noGrp="1"/>
-          </p:cNvSpPr>
-          <p:nvPr/>
-        </p:nvSpPr>
-        <p:spPr>
-          <a:xfrm>
-            <a:off x="5356860" y="3558612"/>
-            <a:ext cx="1630680" cy="323850"/>
-          </a:xfrm>
-          <a:prstGeom prst="rect">
-            <a:avLst/>
-          </a:prstGeom>
-        </p:spPr>
-        <p:txBody>
-          <a:bodyPr wrap="square" lIns="0" tIns="0" rIns="0" bIns="0" anchor="t"/>
-          <a:lstStyle/>
-          <a:p>
-            <a:pPr marL="0" indent="0">
-              <a:buNone/>
-            </a:pPr>
-            <a:r>
-              <a:rPr sz="1300">
-                <a:solidFill>
-                  <a:srgbClr val="D8D8D2"/>
-                </a:solidFill>
-                <a:latin typeface="Arial"/>
-                <a:ea typeface="Arial"/>
-                <a:cs typeface="Arial"/>
-              </a:rPr>
-              <a:t>Active and recent listings</a:t>
-            </a:r>
-          </a:p>
-        </p:txBody>
-      </p:sp>
-      <p:sp>
-        <p:nvSpPr>
           <p:cNvPr id="32" name="Category Focus card">
             <a:extLst>
               <a:ext uri="{FF2B5EF4-FFF2-40B4-BE49-F238E27FC236}">
@@ -3206,7 +2864,9 @@
             <a:ext cx="2087880" cy="1466850"/>
           </a:xfrm>
           <a:prstGeom prst="roundRect">
-            <a:avLst/>
+            <a:avLst>
+              <a:gd name="adj" fmla="val 7000"/>
+            </a:avLst>
           </a:prstGeom>
           <a:solidFill>
             <a:srgbClr val="0E0E0E"/>
@@ -3321,168 +2981,6 @@
       </p:sp>
       <p:sp>
         <p:nvSpPr>
-          <p:cNvPr id="35" name="Signal bullet">
-            <a:extLst>
-              <a:ext uri="{FF2B5EF4-FFF2-40B4-BE49-F238E27FC236}">
-                <a16:creationId xmlns:a16="http://schemas.microsoft.com/office/drawing/2014/main" id="{7A6351F8-4C68-48D0-B0B9-9D66CF8A3D68}"/>
-              </a:ext>
-            </a:extLst>
-          </p:cNvPr>
-          <p:cNvSpPr>
-            <a:spLocks noGrp="1"/>
-          </p:cNvSpPr>
-          <p:nvPr/>
-        </p:nvSpPr>
-        <p:spPr>
-          <a:xfrm>
-            <a:off x="7444740" y="3215712"/>
-            <a:ext cx="66675" cy="66675"/>
-          </a:xfrm>
-          <a:prstGeom prst="ellipse">
-            <a:avLst/>
-          </a:prstGeom>
-          <a:solidFill>
-            <a:srgbClr val="FFD426"/>
-          </a:solidFill>
-          <a:ln w="0">
-            <a:noFill/>
-          </a:ln>
-        </p:spPr>
-        <p:txBody>
-          <a:bodyPr/>
-          <a:lstStyle/>
-          <a:p>
-            <a:endParaRPr/>
-          </a:p>
-        </p:txBody>
-      </p:sp>
-      <p:sp>
-        <p:nvSpPr>
-          <p:cNvPr id="36" name="Category Focus item">
-            <a:extLst>
-              <a:ext uri="{FF2B5EF4-FFF2-40B4-BE49-F238E27FC236}">
-                <a16:creationId xmlns:a16="http://schemas.microsoft.com/office/drawing/2014/main" id="{B1A97181-513A-4A9F-A03F-DD5DB8ED741A}"/>
-              </a:ext>
-            </a:extLst>
-          </p:cNvPr>
-          <p:cNvSpPr>
-            <a:spLocks noGrp="1"/>
-          </p:cNvSpPr>
-          <p:nvPr/>
-        </p:nvSpPr>
-        <p:spPr>
-          <a:xfrm>
-            <a:off x="7578090" y="3149037"/>
-            <a:ext cx="1630680" cy="323850"/>
-          </a:xfrm>
-          <a:prstGeom prst="rect">
-            <a:avLst/>
-          </a:prstGeom>
-        </p:spPr>
-        <p:txBody>
-          <a:bodyPr wrap="square" lIns="0" tIns="0" rIns="0" bIns="0" anchor="t"/>
-          <a:lstStyle/>
-          <a:p>
-            <a:pPr marL="0" indent="0">
-              <a:buNone/>
-            </a:pPr>
-            <a:r>
-              <a:rPr sz="1300">
-                <a:solidFill>
-                  <a:srgbClr val="D8D8D2"/>
-                </a:solidFill>
-                <a:latin typeface="Arial"/>
-                <a:ea typeface="Arial"/>
-                <a:cs typeface="Arial"/>
-              </a:rPr>
-              <a:t>Repeated category/subcategory</a:t>
-            </a:r>
-          </a:p>
-        </p:txBody>
-      </p:sp>
-      <p:sp>
-        <p:nvSpPr>
-          <p:cNvPr id="37" name="Signal bullet">
-            <a:extLst>
-              <a:ext uri="{FF2B5EF4-FFF2-40B4-BE49-F238E27FC236}">
-                <a16:creationId xmlns:a16="http://schemas.microsoft.com/office/drawing/2014/main" id="{3BE1C13B-6D87-4F60-9FC9-A66B16638F60}"/>
-              </a:ext>
-            </a:extLst>
-          </p:cNvPr>
-          <p:cNvSpPr>
-            <a:spLocks noGrp="1"/>
-          </p:cNvSpPr>
-          <p:nvPr/>
-        </p:nvSpPr>
-        <p:spPr>
-          <a:xfrm>
-            <a:off x="7444740" y="3625287"/>
-            <a:ext cx="66675" cy="66675"/>
-          </a:xfrm>
-          <a:prstGeom prst="ellipse">
-            <a:avLst/>
-          </a:prstGeom>
-          <a:solidFill>
-            <a:srgbClr val="FFD426"/>
-          </a:solidFill>
-          <a:ln w="0">
-            <a:noFill/>
-          </a:ln>
-        </p:spPr>
-        <p:txBody>
-          <a:bodyPr/>
-          <a:lstStyle/>
-          <a:p>
-            <a:endParaRPr/>
-          </a:p>
-        </p:txBody>
-      </p:sp>
-      <p:sp>
-        <p:nvSpPr>
-          <p:cNvPr id="38" name="Category Focus item">
-            <a:extLst>
-              <a:ext uri="{FF2B5EF4-FFF2-40B4-BE49-F238E27FC236}">
-                <a16:creationId xmlns:a16="http://schemas.microsoft.com/office/drawing/2014/main" id="{0C6E2724-9D5D-4507-85DB-BC4B505BB9E6}"/>
-              </a:ext>
-            </a:extLst>
-          </p:cNvPr>
-          <p:cNvSpPr>
-            <a:spLocks noGrp="1"/>
-          </p:cNvSpPr>
-          <p:nvPr/>
-        </p:nvSpPr>
-        <p:spPr>
-          <a:xfrm>
-            <a:off x="7578090" y="3558612"/>
-            <a:ext cx="1630680" cy="323850"/>
-          </a:xfrm>
-          <a:prstGeom prst="rect">
-            <a:avLst/>
-          </a:prstGeom>
-        </p:spPr>
-        <p:txBody>
-          <a:bodyPr wrap="square" lIns="0" tIns="0" rIns="0" bIns="0" anchor="t"/>
-          <a:lstStyle/>
-          <a:p>
-            <a:pPr marL="0" indent="0">
-              <a:buNone/>
-            </a:pPr>
-            <a:r>
-              <a:rPr sz="1300">
-                <a:solidFill>
-                  <a:srgbClr val="D8D8D2"/>
-                </a:solidFill>
-                <a:latin typeface="Arial"/>
-                <a:ea typeface="Arial"/>
-                <a:cs typeface="Arial"/>
-              </a:rPr>
-              <a:t>Category-specific thresholds</a:t>
-            </a:r>
-          </a:p>
-        </p:txBody>
-      </p:sp>
-      <p:sp>
-        <p:nvSpPr>
           <p:cNvPr id="39" name="Buyer Demand card">
             <a:extLst>
               <a:ext uri="{FF2B5EF4-FFF2-40B4-BE49-F238E27FC236}">
@@ -3501,7 +2999,9 @@
             <a:ext cx="2087880" cy="1466850"/>
           </a:xfrm>
           <a:prstGeom prst="roundRect">
-            <a:avLst/>
+            <a:avLst>
+              <a:gd name="adj" fmla="val 7000"/>
+            </a:avLst>
           </a:prstGeom>
           <a:solidFill>
             <a:srgbClr val="0E0E0E"/>
@@ -3616,168 +3116,6 @@
       </p:sp>
       <p:sp>
         <p:nvSpPr>
-          <p:cNvPr id="42" name="Signal bullet">
-            <a:extLst>
-              <a:ext uri="{FF2B5EF4-FFF2-40B4-BE49-F238E27FC236}">
-                <a16:creationId xmlns:a16="http://schemas.microsoft.com/office/drawing/2014/main" id="{29AAEA38-388B-4218-AF99-760F3ACB07B3}"/>
-              </a:ext>
-            </a:extLst>
-          </p:cNvPr>
-          <p:cNvSpPr>
-            <a:spLocks noGrp="1"/>
-          </p:cNvSpPr>
-          <p:nvPr/>
-        </p:nvSpPr>
-        <p:spPr>
-          <a:xfrm>
-            <a:off x="9665970" y="3215712"/>
-            <a:ext cx="66675" cy="66675"/>
-          </a:xfrm>
-          <a:prstGeom prst="ellipse">
-            <a:avLst/>
-          </a:prstGeom>
-          <a:solidFill>
-            <a:srgbClr val="FFD426"/>
-          </a:solidFill>
-          <a:ln w="0">
-            <a:noFill/>
-          </a:ln>
-        </p:spPr>
-        <p:txBody>
-          <a:bodyPr/>
-          <a:lstStyle/>
-          <a:p>
-            <a:endParaRPr/>
-          </a:p>
-        </p:txBody>
-      </p:sp>
-      <p:sp>
-        <p:nvSpPr>
-          <p:cNvPr id="43" name="Buyer Demand item">
-            <a:extLst>
-              <a:ext uri="{FF2B5EF4-FFF2-40B4-BE49-F238E27FC236}">
-                <a16:creationId xmlns:a16="http://schemas.microsoft.com/office/drawing/2014/main" id="{6EF00164-93C6-4F9D-A165-828EA0E36D9A}"/>
-              </a:ext>
-            </a:extLst>
-          </p:cNvPr>
-          <p:cNvSpPr>
-            <a:spLocks noGrp="1"/>
-          </p:cNvSpPr>
-          <p:nvPr/>
-        </p:nvSpPr>
-        <p:spPr>
-          <a:xfrm>
-            <a:off x="9799320" y="3149037"/>
-            <a:ext cx="1630680" cy="323850"/>
-          </a:xfrm>
-          <a:prstGeom prst="rect">
-            <a:avLst/>
-          </a:prstGeom>
-        </p:spPr>
-        <p:txBody>
-          <a:bodyPr wrap="square" lIns="0" tIns="0" rIns="0" bIns="0" anchor="t"/>
-          <a:lstStyle/>
-          <a:p>
-            <a:pPr marL="0" indent="0">
-              <a:buNone/>
-            </a:pPr>
-            <a:r>
-              <a:rPr sz="1300">
-                <a:solidFill>
-                  <a:srgbClr val="D8D8D2"/>
-                </a:solidFill>
-                <a:latin typeface="Arial"/>
-                <a:ea typeface="Arial"/>
-                <a:cs typeface="Arial"/>
-              </a:rPr>
-              <a:t>Engaged ads</a:t>
-            </a:r>
-          </a:p>
-        </p:txBody>
-      </p:sp>
-      <p:sp>
-        <p:nvSpPr>
-          <p:cNvPr id="44" name="Signal bullet">
-            <a:extLst>
-              <a:ext uri="{FF2B5EF4-FFF2-40B4-BE49-F238E27FC236}">
-                <a16:creationId xmlns:a16="http://schemas.microsoft.com/office/drawing/2014/main" id="{25757DBF-E54D-41B9-8864-36A3772C014F}"/>
-              </a:ext>
-            </a:extLst>
-          </p:cNvPr>
-          <p:cNvSpPr>
-            <a:spLocks noGrp="1"/>
-          </p:cNvSpPr>
-          <p:nvPr/>
-        </p:nvSpPr>
-        <p:spPr>
-          <a:xfrm>
-            <a:off x="9665970" y="3625287"/>
-            <a:ext cx="66675" cy="66675"/>
-          </a:xfrm>
-          <a:prstGeom prst="ellipse">
-            <a:avLst/>
-          </a:prstGeom>
-          <a:solidFill>
-            <a:srgbClr val="FFD426"/>
-          </a:solidFill>
-          <a:ln w="0">
-            <a:noFill/>
-          </a:ln>
-        </p:spPr>
-        <p:txBody>
-          <a:bodyPr/>
-          <a:lstStyle/>
-          <a:p>
-            <a:endParaRPr/>
-          </a:p>
-        </p:txBody>
-      </p:sp>
-      <p:sp>
-        <p:nvSpPr>
-          <p:cNvPr id="45" name="Buyer Demand item">
-            <a:extLst>
-              <a:ext uri="{FF2B5EF4-FFF2-40B4-BE49-F238E27FC236}">
-                <a16:creationId xmlns:a16="http://schemas.microsoft.com/office/drawing/2014/main" id="{C27D2C33-21D5-4658-8E6A-35747344CF5E}"/>
-              </a:ext>
-            </a:extLst>
-          </p:cNvPr>
-          <p:cNvSpPr>
-            <a:spLocks noGrp="1"/>
-          </p:cNvSpPr>
-          <p:nvPr/>
-        </p:nvSpPr>
-        <p:spPr>
-          <a:xfrm>
-            <a:off x="9799320" y="3558612"/>
-            <a:ext cx="1630680" cy="323850"/>
-          </a:xfrm>
-          <a:prstGeom prst="rect">
-            <a:avLst/>
-          </a:prstGeom>
-        </p:spPr>
-        <p:txBody>
-          <a:bodyPr wrap="square" lIns="0" tIns="0" rIns="0" bIns="0" anchor="t"/>
-          <a:lstStyle/>
-          <a:p>
-            <a:pPr marL="0" indent="0">
-              <a:buNone/>
-            </a:pPr>
-            <a:r>
-              <a:rPr sz="1300">
-                <a:solidFill>
-                  <a:srgbClr val="D8D8D2"/>
-                </a:solidFill>
-                <a:latin typeface="Arial"/>
-                <a:ea typeface="Arial"/>
-                <a:cs typeface="Arial"/>
-              </a:rPr>
-              <a:t>Unique buyers, engagement rate</a:t>
-            </a:r>
-          </a:p>
-        </p:txBody>
-      </p:sp>
-      <p:sp>
-        <p:nvSpPr>
           <p:cNvPr id="46" name="Scoring Flow label">
             <a:extLst>
               <a:ext uri="{FF2B5EF4-FFF2-40B4-BE49-F238E27FC236}">
@@ -3807,7 +3145,7 @@
               <a:buNone/>
             </a:pPr>
             <a:r>
-              <a:rPr sz="1800" b="1">
+              <a:rPr sz="1800" b="1" dirty="0">
                 <a:solidFill>
                   <a:srgbClr val="FFD426"/>
                 </a:solidFill>
@@ -4442,6 +3780,336 @@
           </a:p>
         </p:txBody>
       </p:sp>
+      <p:sp>
+        <p:nvSpPr>
+          <p:cNvPr id="62" name="Business Markers list"/>
+          <p:cNvSpPr>
+            <a:spLocks noGrp="1"/>
+          </p:cNvSpPr>
+          <p:nvPr/>
+        </p:nvSpPr>
+        <p:spPr>
+          <a:xfrm>
+            <a:off x="609600" y="3149037"/>
+            <a:ext cx="1913350" cy="720000"/>
+          </a:xfrm>
+          <a:prstGeom prst="rect">
+            <a:avLst/>
+          </a:prstGeom>
+          <a:noFill/>
+          <a:ln w="0">
+            <a:noFill/>
+          </a:ln>
+        </p:spPr>
+        <p:txBody>
+          <a:bodyPr lIns="0" tIns="0" rIns="0" bIns="0"/>
+          <a:lstStyle/>
+          <a:p>
+            <a:pPr marL="361950" indent="-285750" algn="l">
+              <a:buClr>
+                <a:srgbClr val="FFD525"/>
+              </a:buClr>
+              <a:buFont typeface="Wingdings" pitchFamily="2" charset="2"/>
+              <a:buChar char="§"/>
+            </a:pPr>
+            <a:r>
+              <a:rPr sz="1300" dirty="0">
+                <a:solidFill>
+                  <a:srgbClr val="D8D8D2"/>
+                </a:solidFill>
+                <a:latin typeface="Arial"/>
+                <a:ea typeface="Arial"/>
+                <a:cs typeface="Arial"/>
+              </a:rPr>
+              <a:t>Corporate bank flag</a:t>
+            </a:r>
+          </a:p>
+          <a:p>
+            <a:pPr marL="361950" indent="-285750" algn="l">
+              <a:buClr>
+                <a:srgbClr val="FFD525"/>
+              </a:buClr>
+              <a:buFont typeface="Wingdings" pitchFamily="2" charset="2"/>
+              <a:buChar char="§"/>
+            </a:pPr>
+            <a:r>
+              <a:rPr sz="1300" dirty="0">
+                <a:solidFill>
+                  <a:srgbClr val="D8D8D2"/>
+                </a:solidFill>
+                <a:latin typeface="Arial"/>
+                <a:ea typeface="Arial"/>
+                <a:cs typeface="Arial"/>
+              </a:rPr>
+              <a:t>External URL</a:t>
+            </a:r>
+          </a:p>
+        </p:txBody>
+      </p:sp>
+      <p:sp>
+        <p:nvSpPr>
+          <p:cNvPr id="63" name="Paid Usage list"/>
+          <p:cNvSpPr>
+            <a:spLocks noGrp="1"/>
+          </p:cNvSpPr>
+          <p:nvPr/>
+        </p:nvSpPr>
+        <p:spPr>
+          <a:xfrm>
+            <a:off x="2830830" y="3149037"/>
+            <a:ext cx="1780000" cy="720000"/>
+          </a:xfrm>
+          <a:prstGeom prst="rect">
+            <a:avLst/>
+          </a:prstGeom>
+          <a:noFill/>
+          <a:ln w="0">
+            <a:noFill/>
+          </a:ln>
+        </p:spPr>
+        <p:txBody>
+          <a:bodyPr lIns="0" tIns="0" rIns="0" bIns="0"/>
+          <a:lstStyle/>
+          <a:p>
+            <a:pPr marL="361950" indent="-285750" algn="l">
+              <a:buClr>
+                <a:srgbClr val="FFD426"/>
+              </a:buClr>
+              <a:buFont typeface="Wingdings" pitchFamily="2" charset="2"/>
+              <a:buChar char="§"/>
+            </a:pPr>
+            <a:r>
+              <a:rPr sz="1300" dirty="0">
+                <a:solidFill>
+                  <a:srgbClr val="D8D8D2"/>
+                </a:solidFill>
+                <a:latin typeface="Arial"/>
+                <a:ea typeface="Arial"/>
+                <a:cs typeface="Arial"/>
+              </a:rPr>
+              <a:t>Paid features</a:t>
+            </a:r>
+          </a:p>
+          <a:p>
+            <a:pPr marL="361950" indent="-285750" algn="l">
+              <a:buClr>
+                <a:srgbClr val="FFD426"/>
+              </a:buClr>
+              <a:buFont typeface="Wingdings" pitchFamily="2" charset="2"/>
+              <a:buChar char="§"/>
+            </a:pPr>
+            <a:r>
+              <a:rPr sz="1300" dirty="0">
+                <a:solidFill>
+                  <a:srgbClr val="D8D8D2"/>
+                </a:solidFill>
+                <a:latin typeface="Arial"/>
+                <a:ea typeface="Arial"/>
+                <a:cs typeface="Arial"/>
+              </a:rPr>
+              <a:t>Pro CPC, invoices</a:t>
+            </a:r>
+          </a:p>
+        </p:txBody>
+      </p:sp>
+      <p:sp>
+        <p:nvSpPr>
+          <p:cNvPr id="64" name="Seller Activity list"/>
+          <p:cNvSpPr>
+            <a:spLocks noGrp="1"/>
+          </p:cNvSpPr>
+          <p:nvPr/>
+        </p:nvSpPr>
+        <p:spPr>
+          <a:xfrm>
+            <a:off x="5052060" y="3149037"/>
+            <a:ext cx="1973580" cy="780000"/>
+          </a:xfrm>
+          <a:prstGeom prst="rect">
+            <a:avLst/>
+          </a:prstGeom>
+          <a:noFill/>
+          <a:ln w="0">
+            <a:noFill/>
+          </a:ln>
+        </p:spPr>
+        <p:txBody>
+          <a:bodyPr lIns="0" tIns="0" rIns="0" bIns="0"/>
+          <a:lstStyle/>
+          <a:p>
+            <a:pPr marL="361950" indent="-285750" algn="l">
+              <a:buClr>
+                <a:srgbClr val="FFD426"/>
+              </a:buClr>
+              <a:buFont typeface="Wingdings" pitchFamily="2" charset="2"/>
+              <a:buChar char="§"/>
+            </a:pPr>
+            <a:r>
+              <a:rPr sz="1300" dirty="0">
+                <a:solidFill>
+                  <a:srgbClr val="D8D8D2"/>
+                </a:solidFill>
+                <a:latin typeface="Arial"/>
+                <a:ea typeface="Arial"/>
+                <a:cs typeface="Arial"/>
+              </a:rPr>
+              <a:t>Listing volume</a:t>
+            </a:r>
+          </a:p>
+          <a:p>
+            <a:pPr marL="361950" indent="-285750" algn="l">
+              <a:buClr>
+                <a:srgbClr val="FFD426"/>
+              </a:buClr>
+              <a:buFont typeface="Wingdings" pitchFamily="2" charset="2"/>
+              <a:buChar char="§"/>
+            </a:pPr>
+            <a:r>
+              <a:rPr sz="1300" dirty="0">
+                <a:solidFill>
+                  <a:srgbClr val="D8D8D2"/>
+                </a:solidFill>
+                <a:latin typeface="Arial"/>
+                <a:ea typeface="Arial"/>
+                <a:cs typeface="Arial"/>
+              </a:rPr>
+              <a:t>Active and recent listings</a:t>
+            </a:r>
+          </a:p>
+        </p:txBody>
+      </p:sp>
+      <p:sp>
+        <p:nvSpPr>
+          <p:cNvPr id="65" name="Category Focus list"/>
+          <p:cNvSpPr>
+            <a:spLocks noGrp="1"/>
+          </p:cNvSpPr>
+          <p:nvPr/>
+        </p:nvSpPr>
+        <p:spPr>
+          <a:xfrm>
+            <a:off x="7273290" y="3149037"/>
+            <a:ext cx="1973580" cy="820000"/>
+          </a:xfrm>
+          <a:prstGeom prst="rect">
+            <a:avLst/>
+          </a:prstGeom>
+          <a:noFill/>
+          <a:ln w="0">
+            <a:noFill/>
+          </a:ln>
+        </p:spPr>
+        <p:txBody>
+          <a:bodyPr lIns="0" tIns="0" rIns="0" bIns="0"/>
+          <a:lstStyle/>
+          <a:p>
+            <a:pPr marL="361950" indent="-285750" algn="l">
+              <a:buClr>
+                <a:srgbClr val="FFD426"/>
+              </a:buClr>
+              <a:buFont typeface="Wingdings" pitchFamily="2" charset="2"/>
+              <a:buChar char="§"/>
+            </a:pPr>
+            <a:r>
+              <a:rPr sz="1300" dirty="0">
+                <a:solidFill>
+                  <a:srgbClr val="D8D8D2"/>
+                </a:solidFill>
+                <a:latin typeface="Arial"/>
+                <a:ea typeface="Arial"/>
+                <a:cs typeface="Arial"/>
+              </a:rPr>
+              <a:t>Repeated category</a:t>
+            </a:r>
+          </a:p>
+          <a:p>
+            <a:pPr marL="361950" indent="-285750" algn="l">
+              <a:buClr>
+                <a:srgbClr val="FFD426"/>
+              </a:buClr>
+              <a:buFont typeface="Wingdings" pitchFamily="2" charset="2"/>
+              <a:buChar char="§"/>
+            </a:pPr>
+            <a:r>
+              <a:rPr sz="1300" dirty="0">
+                <a:solidFill>
+                  <a:srgbClr val="D8D8D2"/>
+                </a:solidFill>
+                <a:latin typeface="Arial"/>
+                <a:ea typeface="Arial"/>
+                <a:cs typeface="Arial"/>
+              </a:rPr>
+              <a:t>Category-specific thresholds</a:t>
+            </a:r>
+          </a:p>
+        </p:txBody>
+      </p:sp>
+      <p:sp>
+        <p:nvSpPr>
+          <p:cNvPr id="66" name="Buyer Demand list"/>
+          <p:cNvSpPr>
+            <a:spLocks noGrp="1"/>
+          </p:cNvSpPr>
+          <p:nvPr/>
+        </p:nvSpPr>
+        <p:spPr>
+          <a:xfrm>
+            <a:off x="9494520" y="3149037"/>
+            <a:ext cx="1780000" cy="820000"/>
+          </a:xfrm>
+          <a:prstGeom prst="rect">
+            <a:avLst/>
+          </a:prstGeom>
+          <a:noFill/>
+          <a:ln w="0">
+            <a:noFill/>
+          </a:ln>
+        </p:spPr>
+        <p:txBody>
+          <a:bodyPr lIns="0" tIns="0" rIns="0" bIns="0"/>
+          <a:lstStyle/>
+          <a:p>
+            <a:pPr marL="361950" indent="-285750" algn="l">
+              <a:buClr>
+                <a:srgbClr val="FFD426"/>
+              </a:buClr>
+              <a:buFont typeface="Wingdings" pitchFamily="2" charset="2"/>
+              <a:buChar char="§"/>
+            </a:pPr>
+            <a:r>
+              <a:rPr sz="1300" dirty="0">
+                <a:solidFill>
+                  <a:srgbClr val="D8D8D2"/>
+                </a:solidFill>
+                <a:latin typeface="Arial"/>
+                <a:ea typeface="Arial"/>
+                <a:cs typeface="Arial"/>
+              </a:rPr>
+              <a:t>Engaged ads</a:t>
+            </a:r>
+          </a:p>
+          <a:p>
+            <a:pPr marL="361950" indent="-285750" algn="l">
+              <a:buClr>
+                <a:srgbClr val="FFD426"/>
+              </a:buClr>
+              <a:buFont typeface="Wingdings" pitchFamily="2" charset="2"/>
+              <a:buChar char="§"/>
+            </a:pPr>
+            <a:r>
+              <a:rPr sz="1300" dirty="0">
+                <a:solidFill>
+                  <a:srgbClr val="D8D8D2"/>
+                </a:solidFill>
+                <a:latin typeface="Arial"/>
+                <a:ea typeface="Arial"/>
+                <a:cs typeface="Arial"/>
+              </a:rPr>
+              <a:t>Unique buyers, engagement rate</a:t>
+            </a:r>
+          </a:p>
+        </p:txBody>
+      </p:sp>
     </p:spTree>
     <p:extLst>
       <p:ext uri="{BB962C8B-B14F-4D97-AF65-F5344CB8AC3E}">
@@ -4452,6 +4120,11 @@
   <p:clrMapOvr>
     <a:masterClrMapping/>
   </p:clrMapOvr>
+  <p:extLst>
+    <p:ext uri="{6950BFC3-D8DA-4A85-94F7-54DA5524770B}">
+      <p188:commentRel xmlns:p188="http://schemas.microsoft.com/office/powerpoint/2018/8/main" r:id="rId3"/>
+    </p:ext>
+  </p:extLst>
 </p:sld>
 </file>
 
@@ -5823,7 +5496,13 @@
         <p:nvGraphicFramePr>
           <p:cNvPr id="17" name="Markdown table"/>
           <p:cNvGraphicFramePr/>
-          <p:nvPr/>
+          <p:nvPr>
+            <p:extLst>
+              <p:ext uri="{D42A27DB-BD31-4B8C-83A1-F6EECF244321}">
+                <p14:modId xmlns:p14="http://schemas.microsoft.com/office/powerpoint/2010/main" val="143331012"/>
+              </p:ext>
+            </p:extLst>
+          </p:nvPr>
         </p:nvGraphicFramePr>
         <p:xfrm>
           <a:off x="552450" y="2417300"/>
@@ -6946,7 +6625,7 @@
                         <a:buNone/>
                       </a:pPr>
                       <a:r>
-                        <a:rPr sz="1100" b="0">
+                        <a:rPr sz="1100" b="0" dirty="0">
                           <a:solidFill>
                             <a:srgbClr val="F3F4F6"/>
                           </a:solidFill>
@@ -7040,7 +6719,7 @@
                         <a:buNone/>
                       </a:pPr>
                       <a:r>
-                        <a:rPr sz="1100" b="0">
+                        <a:rPr sz="1100" b="0" dirty="0">
                           <a:solidFill>
                             <a:srgbClr val="F3F4F6"/>
                           </a:solidFill>
@@ -7252,6 +6931,11 @@
   <p:clrMapOvr>
     <a:masterClrMapping/>
   </p:clrMapOvr>
+  <p:extLst>
+    <p:ext uri="{6950BFC3-D8DA-4A85-94F7-54DA5524770B}">
+      <p188:commentRel xmlns:p188="http://schemas.microsoft.com/office/powerpoint/2018/8/main" r:id="rId3"/>
+    </p:ext>
+  </p:extLst>
 </p:sld>
 </file>
 
@@ -11514,6 +11198,11 @@
   <p:clrMapOvr>
     <a:masterClrMapping/>
   </p:clrMapOvr>
+  <p:extLst>
+    <p:ext uri="{6950BFC3-D8DA-4A85-94F7-54DA5524770B}">
+      <p188:commentRel xmlns:p188="http://schemas.microsoft.com/office/powerpoint/2018/8/main" r:id="rId3"/>
+    </p:ext>
+  </p:extLst>
 </p:sld>
 </file>
 
@@ -12447,7 +12136,7 @@
                         <a:buNone/>
                       </a:pPr>
                       <a:r>
-                        <a:rPr sz="1100" b="0">
+                        <a:rPr sz="1100" b="0" dirty="0">
                           <a:solidFill>
                             <a:srgbClr val="D8D8D2"/>
                           </a:solidFill>
@@ -12494,7 +12183,7 @@
                         <a:buNone/>
                       </a:pPr>
                       <a:r>
-                        <a:rPr sz="1100" b="0">
+                        <a:rPr sz="1100" b="0" dirty="0">
                           <a:solidFill>
                             <a:srgbClr val="D8D8D2"/>
                           </a:solidFill>
@@ -12588,7 +12277,7 @@
               </a:defRPr>
             </a:pPr>
             <a:r>
-              <a:rPr sz="1100" b="0">
+              <a:rPr sz="1100" b="0" dirty="0">
                 <a:solidFill>
                   <a:srgbClr val="F3F4F6"/>
                 </a:solidFill>
@@ -12596,7 +12285,51 @@
                 <a:ea typeface="Arial"/>
                 <a:cs typeface="Arial"/>
               </a:rPr>
-              <a:t>Output: ranked sellers with user_id, smb_score, confidence tier, top reasons, and recommended action.</a:t>
+              <a:t>Output: ranked sellers with </a:t>
+            </a:r>
+            <a:r>
+              <a:rPr sz="1100" b="0" dirty="0" err="1">
+                <a:solidFill>
+                  <a:srgbClr val="F3F4F6"/>
+                </a:solidFill>
+                <a:latin typeface="Arial"/>
+                <a:ea typeface="Arial"/>
+                <a:cs typeface="Arial"/>
+              </a:rPr>
+              <a:t>user_id</a:t>
+            </a:r>
+            <a:r>
+              <a:rPr sz="1100" b="0" dirty="0">
+                <a:solidFill>
+                  <a:srgbClr val="F3F4F6"/>
+                </a:solidFill>
+                <a:latin typeface="Arial"/>
+                <a:ea typeface="Arial"/>
+                <a:cs typeface="Arial"/>
+              </a:rPr>
+              <a:t>, </a:t>
+            </a:r>
+            <a:r>
+              <a:rPr sz="1100" b="0" dirty="0" err="1">
+                <a:solidFill>
+                  <a:srgbClr val="F3F4F6"/>
+                </a:solidFill>
+                <a:latin typeface="Arial"/>
+                <a:ea typeface="Arial"/>
+                <a:cs typeface="Arial"/>
+              </a:rPr>
+              <a:t>smb_score</a:t>
+            </a:r>
+            <a:r>
+              <a:rPr sz="1100" b="0" dirty="0">
+                <a:solidFill>
+                  <a:srgbClr val="F3F4F6"/>
+                </a:solidFill>
+                <a:latin typeface="Arial"/>
+                <a:ea typeface="Arial"/>
+                <a:cs typeface="Arial"/>
+              </a:rPr>
+              <a:t>, confidence tier, top reasons, and recommended action.</a:t>
             </a:r>
           </a:p>
         </p:txBody>
@@ -12676,6 +12409,11 @@
   <p:clrMapOvr>
     <a:masterClrMapping/>
   </p:clrMapOvr>
+  <p:extLst>
+    <p:ext uri="{6950BFC3-D8DA-4A85-94F7-54DA5524770B}">
+      <p188:commentRel xmlns:p188="http://schemas.microsoft.com/office/powerpoint/2018/8/main" r:id="rId3"/>
+    </p:ext>
+  </p:extLst>
 </p:sld>
 </file>
 

</xml_diff>